<commit_message>
Reword slide 15 in plain language, per review
"Downstream calls are counted, not attributed" was too compressed -- it needed the
reader to unpack "attributed" before the point landed. Now:

  "A subagent's calls land in the totals -- and can't be separated out"

which states both halves outright: they ARE in the numbers, and they CANNOT be
picked apart from the main loop's. The title runs to two lines at 66 characters; the
accent rule moves down automatically for long titles, and the slide body was
reflowed to keep everything above the page number.

Contents entry and the report's section 7.5 heading follow the same wording, so the
three references stay consistent.

Overlap check across all 19 slides: only the known-benign box padding on the
recommendation slide, confirmed by render.

Co-Authored-By: Claude Opus 5 (1M context) <noreply@anthropic.com>
</commit_message>
<xml_diff>
--- a/results/autobench-claudecode-summary.pptx
+++ b/results/autobench-claudecode-summary.pptx
@@ -3261,7 +3261,7 @@
                 </a:solidFill>
                 <a:latin typeface="Arial"/>
               </a:rPr>
-              <a:t>Last modified 2026-09-09 12:16 EDT</a:t>
+              <a:t>Last modified 2026-09-09 12:32 EDT</a:t>
             </a:r>
           </a:p>
         </p:txBody>
@@ -8551,7 +8551,7 @@
                 </a:solidFill>
                 <a:latin typeface="Arial"/>
               </a:rPr>
-              <a:t>Downstream calls are counted, not attributed</a:t>
+              <a:t>A subagent's calls land in the totals — and can't be separated out</a:t>
             </a:r>
           </a:p>
         </p:txBody>
@@ -8564,7 +8564,7 @@
         </p:nvSpPr>
         <p:spPr>
           <a:xfrm>
-            <a:off x="640080" y="1481328"/>
+            <a:off x="640080" y="1901952"/>
             <a:ext cx="1005840" cy="45720"/>
           </a:xfrm>
           <a:prstGeom prst="rect">
@@ -8608,8 +8608,8 @@
         </p:nvSpPr>
         <p:spPr>
           <a:xfrm>
-            <a:off x="640080" y="1783080"/>
-            <a:ext cx="10881360" cy="548640"/>
+            <a:off x="640080" y="2084831"/>
+            <a:ext cx="10881360" cy="274320"/>
           </a:xfrm>
           <a:prstGeom prst="rect">
             <a:avLst/>
@@ -8630,19 +8630,7 @@
                 </a:solidFill>
                 <a:latin typeface="Arial"/>
               </a:rPr>
-              <a:t>An LLM call can trigger more LLM calls: a subagent runs its own agent loop. Cortex counts them, because the</a:t>
-            </a:r>
-          </a:p>
-          <a:p>
-            <a:pPr algn="l"/>
-            <a:r>
-              <a:rPr sz="1400" b="0">
-                <a:solidFill>
-                  <a:srgbClr val="2B2B2B"/>
-                </a:solidFill>
-                <a:latin typeface="Arial"/>
-              </a:rPr>
-              <a:t>child's HTTPS_PROXY is inherited by its subprocesses — that traffic crosses the same proxy into the window.</a:t>
+              <a:t>The child's HTTPS_PROXY is inherited by its subprocesses, so a subagent's traffic crosses the same proxy.</a:t>
             </a:r>
           </a:p>
         </p:txBody>
@@ -8656,7 +8644,7 @@
           <p:nvPr/>
         </p:nvGraphicFramePr>
         <p:xfrm>
-          <a:off x="640080" y="2468880"/>
+          <a:off x="640080" y="2423160"/>
           <a:ext cx="10881360" cy="1463040"/>
         </p:xfrm>
         <a:graphic>
@@ -8921,7 +8909,7 @@
         </p:nvSpPr>
         <p:spPr>
           <a:xfrm>
-            <a:off x="640080" y="3977639"/>
+            <a:off x="640080" y="3950208"/>
             <a:ext cx="10881360" cy="274320"/>
           </a:xfrm>
           <a:prstGeom prst="rect">
@@ -8957,7 +8945,7 @@
           <p:nvPr/>
         </p:nvGraphicFramePr>
         <p:xfrm>
-          <a:off x="640080" y="4343400"/>
+          <a:off x="640080" y="4279392"/>
           <a:ext cx="10881360" cy="1170432"/>
         </p:xfrm>
         <a:graphic>
@@ -9267,8 +9255,8 @@
         </p:nvSpPr>
         <p:spPr>
           <a:xfrm>
-            <a:off x="640080" y="5532120"/>
-            <a:ext cx="10241280" cy="868680"/>
+            <a:off x="640080" y="5486400"/>
+            <a:ext cx="10241280" cy="822960"/>
           </a:xfrm>
           <a:prstGeom prst="roundRect">
             <a:avLst/>
@@ -13680,7 +13668,7 @@
                 </a:solidFill>
                 <a:latin typeface="Arial"/>
               </a:rPr>
-              <a:t>Downstream calls are counted, not attributed</a:t>
+              <a:t>A subagent's calls land in the totals</a:t>
             </a:r>
           </a:p>
         </p:txBody>

</xml_diff>

<commit_message>
Fix two stale figures on the vocabulary slide
Both were left behind by earlier corrections that were applied everywhere
except here:

- The Cell example read "xlsx-fin-colors / ON / sonnet-5, n=8". No cell has
  n=8 since f00124a removed the accidentally pooled dev sweeps; that cell
  is n=5. Illustrating the definition with a value the profile no longer
  contains invites a reader to check it and find nothing.
- LLM calls per task read "5 to 24 here", the pre-n=30 range. EVALUATION.md
  and README already say 2 to 29.

Slide 5 rendered and checked. Deck and PDF regenerated.

Co-Authored-By: Claude Opus 5 <noreply@anthropic.com>
</commit_message>
<xml_diff>
--- a/results/autobench-claudecode-summary.pptx
+++ b/results/autobench-claudecode-summary.pptx
@@ -3261,7 +3261,7 @@
                 </a:solidFill>
                 <a:latin typeface="Arial"/>
               </a:rPr>
-              <a:t>Last modified 2026-09-09 21:09 EDT</a:t>
+              <a:t>Last modified 2026-09-09 21:10 EDT</a:t>
             </a:r>
           </a:p>
         </p:txBody>
@@ -16523,7 +16523,7 @@
                           </a:solidFill>
                           <a:latin typeface="Arial"/>
                         </a:rPr>
-                        <a:t>one (task × arm × model), measured over n repetitions — e.g. xlsx-fin-colors / ON / sonnet-5, n=8</a:t>
+                        <a:t>one (task × arm × model), measured over n repetitions — e.g. xlsx-fin-colors / ON / sonnet-5, n=5</a:t>
                       </a:r>
                     </a:p>
                   </a:txBody>
@@ -16619,7 +16619,7 @@
                           </a:solidFill>
                           <a:latin typeface="Arial"/>
                         </a:rPr>
-                        <a:t>ONE /v1/chat/completions on the wire. A task makes SEVERAL — 5 to 24 here</a:t>
+                        <a:t>ONE /v1/chat/completions on the wire. A task makes SEVERAL — 2 to 29 here</a:t>
                       </a:r>
                     </a:p>
                   </a:txBody>

</xml_diff>